<commit_message>
Clarify first-freeze results and subsequent v2 evaluation provenance
</commit_message>
<xml_diff>
--- a/docs/LeakShield-Freeze-v2.pptx
+++ b/docs/LeakShield-Freeze-v2.pptx
@@ -2,20 +2,20 @@
 <file path=ppt/presentation.xml><?xml version="1.0" encoding="utf-8"?>
 <p:presentation xmlns:p="http://schemas.openxmlformats.org/presentationml/2006/main">
   <p:sldMasterIdLst>
-    <p:sldMasterId xmlns:r="http://schemas.openxmlformats.org/officeDocument/2006/relationships" id="2147483648" r:id="R77eaa1fe7d644f44"/>
+    <p:sldMasterId xmlns:r="http://schemas.openxmlformats.org/officeDocument/2006/relationships" id="2147483648" r:id="R960af26beab44440"/>
   </p:sldMasterIdLst>
   <p:notesMasterIdLst>
-    <p:notesMasterId xmlns:r="http://schemas.openxmlformats.org/officeDocument/2006/relationships" r:id="R4deddb5fe6b043a4"/>
+    <p:notesMasterId xmlns:r="http://schemas.openxmlformats.org/officeDocument/2006/relationships" r:id="R039edfd1566a42df"/>
   </p:notesMasterIdLst>
   <p:sldIdLst>
-    <p:sldId xmlns:r="http://schemas.openxmlformats.org/officeDocument/2006/relationships" id="256" r:id="Rdc3d3c0c75a548b5"/>
-    <p:sldId xmlns:r="http://schemas.openxmlformats.org/officeDocument/2006/relationships" id="257" r:id="R0f19ca80162c447c"/>
-    <p:sldId xmlns:r="http://schemas.openxmlformats.org/officeDocument/2006/relationships" id="258" r:id="R1a0aef9e20e54150"/>
-    <p:sldId xmlns:r="http://schemas.openxmlformats.org/officeDocument/2006/relationships" id="259" r:id="R9401d6833547444f"/>
-    <p:sldId xmlns:r="http://schemas.openxmlformats.org/officeDocument/2006/relationships" id="260" r:id="R2221fc330ce54cb9"/>
-    <p:sldId xmlns:r="http://schemas.openxmlformats.org/officeDocument/2006/relationships" id="261" r:id="Re95f14fbee0f4711"/>
-    <p:sldId xmlns:r="http://schemas.openxmlformats.org/officeDocument/2006/relationships" id="262" r:id="R18fea6523fbc428a"/>
-    <p:sldId xmlns:r="http://schemas.openxmlformats.org/officeDocument/2006/relationships" id="263" r:id="R3ceb6b33ba474670"/>
+    <p:sldId xmlns:r="http://schemas.openxmlformats.org/officeDocument/2006/relationships" id="256" r:id="R31d3f09ba2b14ed3"/>
+    <p:sldId xmlns:r="http://schemas.openxmlformats.org/officeDocument/2006/relationships" id="257" r:id="R3696c3dbd1b7488c"/>
+    <p:sldId xmlns:r="http://schemas.openxmlformats.org/officeDocument/2006/relationships" id="258" r:id="Rb80b113f96f74bc8"/>
+    <p:sldId xmlns:r="http://schemas.openxmlformats.org/officeDocument/2006/relationships" id="259" r:id="Rba4a66eefbf54bf8"/>
+    <p:sldId xmlns:r="http://schemas.openxmlformats.org/officeDocument/2006/relationships" id="260" r:id="R69c09395bd3243eb"/>
+    <p:sldId xmlns:r="http://schemas.openxmlformats.org/officeDocument/2006/relationships" id="261" r:id="R2102615f5bcc460f"/>
+    <p:sldId xmlns:r="http://schemas.openxmlformats.org/officeDocument/2006/relationships" id="262" r:id="R7fb6e774ff6e49a3"/>
+    <p:sldId xmlns:r="http://schemas.openxmlformats.org/officeDocument/2006/relationships" id="263" r:id="R7d48f791f5ec40de"/>
   </p:sldIdLst>
   <p:sldSz cx="12191695" cy="6858000"/>
   <p:notesSz cx="6858000" cy="9144000"/>
@@ -856,7 +856,7 @@
           <a:lstStyle xmlns:a="http://schemas.openxmlformats.org/drawingml/2006/main"/>
           <a:p xmlns:a="http://schemas.openxmlformats.org/drawingml/2006/main">
             <a:r>
-              <a:t>Sources: results/freeze-v2-groq/heldout-leakshield.json, heldout-baseline.json and robustness-leakshield.json. Model openai/gpt-oss-20b. Frozen source 05d1afc5cda7309edbc7c733aaca42353128788f. Measured-stage overhead excludes inference and uninstrumented audit/vault work. Wall time is separate. Original expected actions and contract explanations are retained. Provider/user leak flags use limited declared assertions, not proof of arbitrary zero leakage. Prior access tests used some authored slices, so not independently blinded.</a:t>
+              <a:t>Sources: results/freeze-v2-groq/heldout-leakshield.json, heldout-baseline.json and robustness-leakshield.json. Historical v1 sources: results/heldout-leakshield.json and results/heldout-baseline.json. First freeze (eval-freeze, v1): 48/60 exact actions, provider leaks 12 → 1. eval-freeze-v2 was tagged after the v1 held-out run; the changes between them were developed on dev and benign prompts only. v2 is not a new blinded evaluation. Model openai/gpt-oss-20b. Frozen source 05d1afc5cda7309edbc7c733aaca42353128788f. Precision 0.865; recall 1. Measured-stage overhead excludes inference and uninstrumented audit/vault work. Wall time is separate. Original expected actions and contract explanations are retained. Provider/user leak flags use limited declared assertions, not proof of arbitrary zero leakage. Prior access tests used some authored slices, so not independently blinded.</a:t>
             </a:r>
           </a:p>
         </p:txBody>
@@ -4093,17 +4093,17 @@
   </p:cSld>
   <p:clrMap bg1="lt1" tx1="dk1" bg2="lt2" tx2="dk2" accent1="accent1" accent2="accent2" accent3="accent3" accent4="accent4" accent5="accent5" accent6="accent6" hlink="hlink" folHlink="folHlink"/>
   <p:sldLayoutIdLst>
-    <p:sldLayoutId xmlns:r="http://schemas.openxmlformats.org/officeDocument/2006/relationships" id="2147483649" r:id="R123a93b892b848be"/>
-    <p:sldLayoutId xmlns:r="http://schemas.openxmlformats.org/officeDocument/2006/relationships" id="2147483650" r:id="R63e2445810f1459f"/>
-    <p:sldLayoutId xmlns:r="http://schemas.openxmlformats.org/officeDocument/2006/relationships" id="2147483651" r:id="Rb73ca820f9ff4c85"/>
-    <p:sldLayoutId xmlns:r="http://schemas.openxmlformats.org/officeDocument/2006/relationships" id="2147483652" r:id="R48328aa24ccd4869"/>
-    <p:sldLayoutId xmlns:r="http://schemas.openxmlformats.org/officeDocument/2006/relationships" id="2147483653" r:id="Rc9b32d22bdd74894"/>
-    <p:sldLayoutId xmlns:r="http://schemas.openxmlformats.org/officeDocument/2006/relationships" id="2147483654" r:id="Rca23f222294f4321"/>
-    <p:sldLayoutId xmlns:r="http://schemas.openxmlformats.org/officeDocument/2006/relationships" id="2147483655" r:id="R0c752228255c4c5c"/>
-    <p:sldLayoutId xmlns:r="http://schemas.openxmlformats.org/officeDocument/2006/relationships" id="2147483656" r:id="Rf94fd79d319748f3"/>
-    <p:sldLayoutId xmlns:r="http://schemas.openxmlformats.org/officeDocument/2006/relationships" id="2147483657" r:id="Rcd522b754d824e0b"/>
-    <p:sldLayoutId xmlns:r="http://schemas.openxmlformats.org/officeDocument/2006/relationships" id="2147483658" r:id="Rf811e46f0114451e"/>
-    <p:sldLayoutId xmlns:r="http://schemas.openxmlformats.org/officeDocument/2006/relationships" id="2147483659" r:id="R1886ac1e21af4af1"/>
+    <p:sldLayoutId xmlns:r="http://schemas.openxmlformats.org/officeDocument/2006/relationships" id="2147483649" r:id="R6d94a4b9a07c49dd"/>
+    <p:sldLayoutId xmlns:r="http://schemas.openxmlformats.org/officeDocument/2006/relationships" id="2147483650" r:id="Ra673de3505b0499d"/>
+    <p:sldLayoutId xmlns:r="http://schemas.openxmlformats.org/officeDocument/2006/relationships" id="2147483651" r:id="R2489368d98be437d"/>
+    <p:sldLayoutId xmlns:r="http://schemas.openxmlformats.org/officeDocument/2006/relationships" id="2147483652" r:id="Rcc8b8e9341ec44a4"/>
+    <p:sldLayoutId xmlns:r="http://schemas.openxmlformats.org/officeDocument/2006/relationships" id="2147483653" r:id="Rb59faaac5bf74741"/>
+    <p:sldLayoutId xmlns:r="http://schemas.openxmlformats.org/officeDocument/2006/relationships" id="2147483654" r:id="Ra1de9c6bf7374fdb"/>
+    <p:sldLayoutId xmlns:r="http://schemas.openxmlformats.org/officeDocument/2006/relationships" id="2147483655" r:id="R4ceb22d16acd43dc"/>
+    <p:sldLayoutId xmlns:r="http://schemas.openxmlformats.org/officeDocument/2006/relationships" id="2147483656" r:id="Recface6026c34791"/>
+    <p:sldLayoutId xmlns:r="http://schemas.openxmlformats.org/officeDocument/2006/relationships" id="2147483657" r:id="R91ae59aadb444efe"/>
+    <p:sldLayoutId xmlns:r="http://schemas.openxmlformats.org/officeDocument/2006/relationships" id="2147483658" r:id="R0536ab899cc24b8b"/>
+    <p:sldLayoutId xmlns:r="http://schemas.openxmlformats.org/officeDocument/2006/relationships" id="2147483659" r:id="R41743497bcc34c23"/>
   </p:sldLayoutIdLst>
   <p:txStyles>
     <p:titleStyle>
@@ -6183,7 +6183,7 @@
           <p:cNvPr id="5" name="Table 4">
             <a:extLst xmlns:a="http://schemas.openxmlformats.org/drawingml/2006/main">
               <a:ext uri="{FF2B5EF4-FFF2-40B4-BE49-F238E27FC236}">
-                <a16:creationId xmlns:a16="http://schemas.microsoft.com/office/drawing/2014/main" id="{C13AA48E-9C4D-45C5-B90B-DFA7772BAFD6}"/>
+                <a16:creationId xmlns:a16="http://schemas.microsoft.com/office/drawing/2014/main" id="{27221BCB-01B5-498B-863A-99E20A827C41}"/>
               </a:ext>
             </a:extLst>
           </p:cNvPr>
@@ -7007,7 +7007,7 @@
           <p:cNvPr id="5" name="Table 4">
             <a:extLst xmlns:a="http://schemas.openxmlformats.org/drawingml/2006/main">
               <a:ext uri="{FF2B5EF4-FFF2-40B4-BE49-F238E27FC236}">
-                <a16:creationId xmlns:a16="http://schemas.microsoft.com/office/drawing/2014/main" id="{7B39E4E0-8ACD-431B-92EC-DDFDEE762251}"/>
+                <a16:creationId xmlns:a16="http://schemas.microsoft.com/office/drawing/2014/main" id="{782CE874-3E73-4D46-8D21-040634F3BC3C}"/>
               </a:ext>
             </a:extLst>
           </p:cNvPr>
@@ -7328,8 +7328,8 @@
         </p:nvSpPr>
         <p:spPr>
           <a:xfrm xmlns:a="http://schemas.openxmlformats.org/drawingml/2006/main">
-            <a:off x="685800" y="5394960"/>
-            <a:ext cx="10698480" cy="670560"/>
+            <a:off x="685800" y="4991100"/>
+            <a:ext cx="10698480" cy="960120"/>
           </a:xfrm>
           <a:prstGeom xmlns:a="http://schemas.openxmlformats.org/drawingml/2006/main" prst="rect">
             <a:avLst/>
@@ -7357,7 +7357,7 @@
               </a:defRPr>
             </a:pPr>
             <a:r>
-              <a:t>Precision 0.865; recall 1. Overhead excludes model time and uninstrumented audit/vault work. These are team-authored cases.</a:t>
+              <a:t>First freeze (eval-freeze, v1): 48/60 exact actions, provider leaks 12 → 1. eval-freeze-v2 was tagged after the v1 held-out run; the changes between them were developed on dev and benign prompts only. Overhead excludes model time and uninstrumented audit/vault work.</a:t>
             </a:r>
           </a:p>
         </p:txBody>
@@ -7546,7 +7546,7 @@
           <p:cNvPr id="5" name="Table 4">
             <a:extLst xmlns:a="http://schemas.openxmlformats.org/drawingml/2006/main">
               <a:ext uri="{FF2B5EF4-FFF2-40B4-BE49-F238E27FC236}">
-                <a16:creationId xmlns:a16="http://schemas.microsoft.com/office/drawing/2014/main" id="{366252F8-5414-4455-A5E4-1C4D10BB5A7A}"/>
+                <a16:creationId xmlns:a16="http://schemas.microsoft.com/office/drawing/2014/main" id="{25CB013A-7ADB-4154-AF97-73098A33EB38}"/>
               </a:ext>
             </a:extLst>
           </p:cNvPr>
@@ -8105,7 +8105,7 @@
           <p:cNvPr id="5" name="Table 4">
             <a:extLst xmlns:a="http://schemas.openxmlformats.org/drawingml/2006/main">
               <a:ext uri="{FF2B5EF4-FFF2-40B4-BE49-F238E27FC236}">
-                <a16:creationId xmlns:a16="http://schemas.microsoft.com/office/drawing/2014/main" id="{C7895C93-9525-4F3B-B5C3-8DCD7EACBC8F}"/>
+                <a16:creationId xmlns:a16="http://schemas.microsoft.com/office/drawing/2014/main" id="{B72D3640-CBB2-4319-8CE9-FC04C5D6F8C6}"/>
               </a:ext>
             </a:extLst>
           </p:cNvPr>

</xml_diff>

<commit_message>
Finalize team tagline, canonical rehearsal script and account-owner handoff
</commit_message>
<xml_diff>
--- a/docs/LeakShield-Freeze-v2.pptx
+++ b/docs/LeakShield-Freeze-v2.pptx
@@ -2,20 +2,20 @@
 <file path=ppt/presentation.xml><?xml version="1.0" encoding="utf-8"?>
 <p:presentation xmlns:p="http://schemas.openxmlformats.org/presentationml/2006/main">
   <p:sldMasterIdLst>
-    <p:sldMasterId xmlns:r="http://schemas.openxmlformats.org/officeDocument/2006/relationships" id="2147483648" r:id="R960af26beab44440"/>
+    <p:sldMasterId xmlns:r="http://schemas.openxmlformats.org/officeDocument/2006/relationships" id="2147483648" r:id="R13d42c1d7a8a4fa9"/>
   </p:sldMasterIdLst>
   <p:notesMasterIdLst>
-    <p:notesMasterId xmlns:r="http://schemas.openxmlformats.org/officeDocument/2006/relationships" r:id="R039edfd1566a42df"/>
+    <p:notesMasterId xmlns:r="http://schemas.openxmlformats.org/officeDocument/2006/relationships" r:id="Re4b036bb8e394c00"/>
   </p:notesMasterIdLst>
   <p:sldIdLst>
-    <p:sldId xmlns:r="http://schemas.openxmlformats.org/officeDocument/2006/relationships" id="256" r:id="R31d3f09ba2b14ed3"/>
-    <p:sldId xmlns:r="http://schemas.openxmlformats.org/officeDocument/2006/relationships" id="257" r:id="R3696c3dbd1b7488c"/>
-    <p:sldId xmlns:r="http://schemas.openxmlformats.org/officeDocument/2006/relationships" id="258" r:id="Rb80b113f96f74bc8"/>
-    <p:sldId xmlns:r="http://schemas.openxmlformats.org/officeDocument/2006/relationships" id="259" r:id="Rba4a66eefbf54bf8"/>
-    <p:sldId xmlns:r="http://schemas.openxmlformats.org/officeDocument/2006/relationships" id="260" r:id="R69c09395bd3243eb"/>
-    <p:sldId xmlns:r="http://schemas.openxmlformats.org/officeDocument/2006/relationships" id="261" r:id="R2102615f5bcc460f"/>
-    <p:sldId xmlns:r="http://schemas.openxmlformats.org/officeDocument/2006/relationships" id="262" r:id="R7fb6e774ff6e49a3"/>
-    <p:sldId xmlns:r="http://schemas.openxmlformats.org/officeDocument/2006/relationships" id="263" r:id="R7d48f791f5ec40de"/>
+    <p:sldId xmlns:r="http://schemas.openxmlformats.org/officeDocument/2006/relationships" id="256" r:id="R439ecd025ae94eb4"/>
+    <p:sldId xmlns:r="http://schemas.openxmlformats.org/officeDocument/2006/relationships" id="257" r:id="R3c7774203c6541df"/>
+    <p:sldId xmlns:r="http://schemas.openxmlformats.org/officeDocument/2006/relationships" id="258" r:id="Rb05affba3e47471b"/>
+    <p:sldId xmlns:r="http://schemas.openxmlformats.org/officeDocument/2006/relationships" id="259" r:id="R4c3a7d91379f42ec"/>
+    <p:sldId xmlns:r="http://schemas.openxmlformats.org/officeDocument/2006/relationships" id="260" r:id="R4989372c6ff74514"/>
+    <p:sldId xmlns:r="http://schemas.openxmlformats.org/officeDocument/2006/relationships" id="261" r:id="Rf4938b3d574c4d4d"/>
+    <p:sldId xmlns:r="http://schemas.openxmlformats.org/officeDocument/2006/relationships" id="262" r:id="R0ee0d869ab394c3b"/>
+    <p:sldId xmlns:r="http://schemas.openxmlformats.org/officeDocument/2006/relationships" id="263" r:id="Rc81621ccda354cd6"/>
   </p:sldIdLst>
   <p:sldSz cx="12191695" cy="6858000"/>
   <p:notesSz cx="6858000" cy="9144000"/>
@@ -576,7 +576,7 @@
           <a:lstStyle xmlns:a="http://schemas.openxmlformats.org/drawingml/2006/main"/>
           <a:p xmlns:a="http://schemas.openxmlformats.org/drawingml/2006/main">
             <a:r>
-              <a:t>Team roles and five-minute narration: docs/REHEARSAL-AND-NARRATION.md. Frozen source eval-freeze-v2 = 05d1afc5cda7309edbc7c733aaca42353128788f, 15 Oct 2026 17:02:11 IST. Do not apply these results to changed decision code.</a:t>
+              <a:t>Team roles, rehearsal checklist and the single narration script: docs/DEMO.md. Backup video owner: Mahatva (TEAM.md). Frozen source eval-freeze-v2 = 05d1afc5cda7309edbc7c733aaca42353128788f, 15 Oct 2026 17:02:11 IST. Do not apply these results to changed decision code.</a:t>
             </a:r>
           </a:p>
         </p:txBody>
@@ -4093,17 +4093,17 @@
   </p:cSld>
   <p:clrMap bg1="lt1" tx1="dk1" bg2="lt2" tx2="dk2" accent1="accent1" accent2="accent2" accent3="accent3" accent4="accent4" accent5="accent5" accent6="accent6" hlink="hlink" folHlink="folHlink"/>
   <p:sldLayoutIdLst>
-    <p:sldLayoutId xmlns:r="http://schemas.openxmlformats.org/officeDocument/2006/relationships" id="2147483649" r:id="R6d94a4b9a07c49dd"/>
-    <p:sldLayoutId xmlns:r="http://schemas.openxmlformats.org/officeDocument/2006/relationships" id="2147483650" r:id="Ra673de3505b0499d"/>
-    <p:sldLayoutId xmlns:r="http://schemas.openxmlformats.org/officeDocument/2006/relationships" id="2147483651" r:id="R2489368d98be437d"/>
-    <p:sldLayoutId xmlns:r="http://schemas.openxmlformats.org/officeDocument/2006/relationships" id="2147483652" r:id="Rcc8b8e9341ec44a4"/>
-    <p:sldLayoutId xmlns:r="http://schemas.openxmlformats.org/officeDocument/2006/relationships" id="2147483653" r:id="Rb59faaac5bf74741"/>
-    <p:sldLayoutId xmlns:r="http://schemas.openxmlformats.org/officeDocument/2006/relationships" id="2147483654" r:id="Ra1de9c6bf7374fdb"/>
-    <p:sldLayoutId xmlns:r="http://schemas.openxmlformats.org/officeDocument/2006/relationships" id="2147483655" r:id="R4ceb22d16acd43dc"/>
-    <p:sldLayoutId xmlns:r="http://schemas.openxmlformats.org/officeDocument/2006/relationships" id="2147483656" r:id="Recface6026c34791"/>
-    <p:sldLayoutId xmlns:r="http://schemas.openxmlformats.org/officeDocument/2006/relationships" id="2147483657" r:id="R91ae59aadb444efe"/>
-    <p:sldLayoutId xmlns:r="http://schemas.openxmlformats.org/officeDocument/2006/relationships" id="2147483658" r:id="R0536ab899cc24b8b"/>
-    <p:sldLayoutId xmlns:r="http://schemas.openxmlformats.org/officeDocument/2006/relationships" id="2147483659" r:id="R41743497bcc34c23"/>
+    <p:sldLayoutId xmlns:r="http://schemas.openxmlformats.org/officeDocument/2006/relationships" id="2147483649" r:id="R857a876c7ad94514"/>
+    <p:sldLayoutId xmlns:r="http://schemas.openxmlformats.org/officeDocument/2006/relationships" id="2147483650" r:id="Rbf7bf2fd2b284412"/>
+    <p:sldLayoutId xmlns:r="http://schemas.openxmlformats.org/officeDocument/2006/relationships" id="2147483651" r:id="R012de6335f2c4fc1"/>
+    <p:sldLayoutId xmlns:r="http://schemas.openxmlformats.org/officeDocument/2006/relationships" id="2147483652" r:id="R67bcd3aa6cfa452f"/>
+    <p:sldLayoutId xmlns:r="http://schemas.openxmlformats.org/officeDocument/2006/relationships" id="2147483653" r:id="R1bd7f98c8d744df3"/>
+    <p:sldLayoutId xmlns:r="http://schemas.openxmlformats.org/officeDocument/2006/relationships" id="2147483654" r:id="Rf576f9473a654ddf"/>
+    <p:sldLayoutId xmlns:r="http://schemas.openxmlformats.org/officeDocument/2006/relationships" id="2147483655" r:id="Rbfe6a89518174665"/>
+    <p:sldLayoutId xmlns:r="http://schemas.openxmlformats.org/officeDocument/2006/relationships" id="2147483656" r:id="R984f20f359704dad"/>
+    <p:sldLayoutId xmlns:r="http://schemas.openxmlformats.org/officeDocument/2006/relationships" id="2147483657" r:id="R0cc67aa71bd64b8a"/>
+    <p:sldLayoutId xmlns:r="http://schemas.openxmlformats.org/officeDocument/2006/relationships" id="2147483658" r:id="R89f4508bf4124f8a"/>
+    <p:sldLayoutId xmlns:r="http://schemas.openxmlformats.org/officeDocument/2006/relationships" id="2147483659" r:id="R20c970ea712846b8"/>
   </p:sldLayoutIdLst>
   <p:txStyles>
     <p:titleStyle>
@@ -4818,7 +4818,7 @@
         <p:spPr>
           <a:xfrm xmlns:a="http://schemas.openxmlformats.org/drawingml/2006/main">
             <a:off x="640080" y="2423160"/>
-            <a:ext cx="10881360" cy="1828800"/>
+            <a:ext cx="10881360" cy="1432560"/>
           </a:xfrm>
           <a:prstGeom xmlns:a="http://schemas.openxmlformats.org/drawingml/2006/main" prst="rect">
             <a:avLst/>
@@ -4846,26 +4846,7 @@
               </a:defRPr>
             </a:pPr>
             <a:r>
-              <a:t>Control which documents</a:t>
-            </a:r>
-          </a:p>
-          <a:p xmlns:a="http://schemas.openxmlformats.org/drawingml/2006/main">
-            <a:pPr>
-              <a:spcAft>
-                <a:spcPts val="1400"/>
-              </a:spcAft>
-              <a:buNone/>
-              <a:defRPr sz="4400" b="1">
-                <a:solidFill>
-                  <a:srgbClr val="F1F5FA"/>
-                </a:solidFill>
-                <a:latin typeface="Aptos"/>
-                <a:ea typeface="Aptos"/>
-                <a:cs typeface="Aptos"/>
-              </a:defRPr>
-            </a:pPr>
-            <a:r>
-              <a:t>reach the model.</a:t>
+              <a:t>Your AI does the work. It never sees the real data.</a:t>
             </a:r>
           </a:p>
         </p:txBody>
@@ -6183,7 +6164,7 @@
           <p:cNvPr id="5" name="Table 4">
             <a:extLst xmlns:a="http://schemas.openxmlformats.org/drawingml/2006/main">
               <a:ext uri="{FF2B5EF4-FFF2-40B4-BE49-F238E27FC236}">
-                <a16:creationId xmlns:a16="http://schemas.microsoft.com/office/drawing/2014/main" id="{27221BCB-01B5-498B-863A-99E20A827C41}"/>
+                <a16:creationId xmlns:a16="http://schemas.microsoft.com/office/drawing/2014/main" id="{18946758-3B63-4620-96AF-0E8B429F5536}"/>
               </a:ext>
             </a:extLst>
           </p:cNvPr>
@@ -7007,7 +6988,7 @@
           <p:cNvPr id="5" name="Table 4">
             <a:extLst xmlns:a="http://schemas.openxmlformats.org/drawingml/2006/main">
               <a:ext uri="{FF2B5EF4-FFF2-40B4-BE49-F238E27FC236}">
-                <a16:creationId xmlns:a16="http://schemas.microsoft.com/office/drawing/2014/main" id="{782CE874-3E73-4D46-8D21-040634F3BC3C}"/>
+                <a16:creationId xmlns:a16="http://schemas.microsoft.com/office/drawing/2014/main" id="{9D83D209-976F-4495-B6AD-075DE49CDB4F}"/>
               </a:ext>
             </a:extLst>
           </p:cNvPr>
@@ -7546,7 +7527,7 @@
           <p:cNvPr id="5" name="Table 4">
             <a:extLst xmlns:a="http://schemas.openxmlformats.org/drawingml/2006/main">
               <a:ext uri="{FF2B5EF4-FFF2-40B4-BE49-F238E27FC236}">
-                <a16:creationId xmlns:a16="http://schemas.microsoft.com/office/drawing/2014/main" id="{25CB013A-7ADB-4154-AF97-73098A33EB38}"/>
+                <a16:creationId xmlns:a16="http://schemas.microsoft.com/office/drawing/2014/main" id="{0A86DB9C-AA5C-41B6-86F3-99B8B961281D}"/>
               </a:ext>
             </a:extLst>
           </p:cNvPr>
@@ -8105,7 +8086,7 @@
           <p:cNvPr id="5" name="Table 4">
             <a:extLst xmlns:a="http://schemas.openxmlformats.org/drawingml/2006/main">
               <a:ext uri="{FF2B5EF4-FFF2-40B4-BE49-F238E27FC236}">
-                <a16:creationId xmlns:a16="http://schemas.microsoft.com/office/drawing/2014/main" id="{B72D3640-CBB2-4319-8CE9-FC04C5D6F8C6}"/>
+                <a16:creationId xmlns:a16="http://schemas.microsoft.com/office/drawing/2014/main" id="{52F1D6CF-FEA5-4099-ADA0-4D13B36D53E3}"/>
               </a:ext>
             </a:extLst>
           </p:cNvPr>

</xml_diff>

<commit_message>
Record verified disabled ZDR in final deck and rehearsal handoff
</commit_message>
<xml_diff>
--- a/docs/LeakShield-Freeze-v2.pptx
+++ b/docs/LeakShield-Freeze-v2.pptx
@@ -2,20 +2,20 @@
 <file path=ppt/presentation.xml><?xml version="1.0" encoding="utf-8"?>
 <p:presentation xmlns:p="http://schemas.openxmlformats.org/presentationml/2006/main">
   <p:sldMasterIdLst>
-    <p:sldMasterId xmlns:r="http://schemas.openxmlformats.org/officeDocument/2006/relationships" id="2147483648" r:id="R13d42c1d7a8a4fa9"/>
+    <p:sldMasterId xmlns:r="http://schemas.openxmlformats.org/officeDocument/2006/relationships" id="2147483648" r:id="R99bbdac70ce34035"/>
   </p:sldMasterIdLst>
   <p:notesMasterIdLst>
-    <p:notesMasterId xmlns:r="http://schemas.openxmlformats.org/officeDocument/2006/relationships" r:id="Re4b036bb8e394c00"/>
+    <p:notesMasterId xmlns:r="http://schemas.openxmlformats.org/officeDocument/2006/relationships" r:id="Rffde398143f34c5f"/>
   </p:notesMasterIdLst>
   <p:sldIdLst>
-    <p:sldId xmlns:r="http://schemas.openxmlformats.org/officeDocument/2006/relationships" id="256" r:id="R439ecd025ae94eb4"/>
-    <p:sldId xmlns:r="http://schemas.openxmlformats.org/officeDocument/2006/relationships" id="257" r:id="R3c7774203c6541df"/>
-    <p:sldId xmlns:r="http://schemas.openxmlformats.org/officeDocument/2006/relationships" id="258" r:id="Rb05affba3e47471b"/>
-    <p:sldId xmlns:r="http://schemas.openxmlformats.org/officeDocument/2006/relationships" id="259" r:id="R4c3a7d91379f42ec"/>
-    <p:sldId xmlns:r="http://schemas.openxmlformats.org/officeDocument/2006/relationships" id="260" r:id="R4989372c6ff74514"/>
-    <p:sldId xmlns:r="http://schemas.openxmlformats.org/officeDocument/2006/relationships" id="261" r:id="Rf4938b3d574c4d4d"/>
-    <p:sldId xmlns:r="http://schemas.openxmlformats.org/officeDocument/2006/relationships" id="262" r:id="R0ee0d869ab394c3b"/>
-    <p:sldId xmlns:r="http://schemas.openxmlformats.org/officeDocument/2006/relationships" id="263" r:id="Rc81621ccda354cd6"/>
+    <p:sldId xmlns:r="http://schemas.openxmlformats.org/officeDocument/2006/relationships" id="256" r:id="R153d5e68120847da"/>
+    <p:sldId xmlns:r="http://schemas.openxmlformats.org/officeDocument/2006/relationships" id="257" r:id="Rd15b523cbeda47b6"/>
+    <p:sldId xmlns:r="http://schemas.openxmlformats.org/officeDocument/2006/relationships" id="258" r:id="R5ca7ae5ac4b84021"/>
+    <p:sldId xmlns:r="http://schemas.openxmlformats.org/officeDocument/2006/relationships" id="259" r:id="R6477da31da7e4c55"/>
+    <p:sldId xmlns:r="http://schemas.openxmlformats.org/officeDocument/2006/relationships" id="260" r:id="R42a01bb9ee81450e"/>
+    <p:sldId xmlns:r="http://schemas.openxmlformats.org/officeDocument/2006/relationships" id="261" r:id="Ra6a7be1e98ac4b38"/>
+    <p:sldId xmlns:r="http://schemas.openxmlformats.org/officeDocument/2006/relationships" id="262" r:id="Rd3ef6489be724093"/>
+    <p:sldId xmlns:r="http://schemas.openxmlformats.org/officeDocument/2006/relationships" id="263" r:id="R64d29074f4134aba"/>
   </p:sldIdLst>
   <p:sldSz cx="12191695" cy="6858000"/>
   <p:notesSz cx="6858000" cy="9144000"/>
@@ -1066,7 +1066,7 @@
           <a:lstStyle xmlns:a="http://schemas.openxmlformats.org/drawingml/2006/main"/>
           <a:p xmlns:a="http://schemas.openxmlformats.org/drawingml/2006/main">
             <a:r>
-              <a:t>Groq source: https://console.groq.com/docs/your-data (checked 15 Oct 2026). Public documentation is not account ZDR confirmation. See docs/GROQ-ACCOUNT-CHECK.md and docs/LIMITATIONS.md. Rehearsals proposed 18:00 and 18:20 IST, not confirmed or recorded. Do not show keys or raw logs.</a:t>
+              <a:t>Masked prompts and approved content reach Groq. In the signed-in Personal organization we checked, inference ZDR is disabled, so we do not claim zero retention. Source: docs/GROQ-ACCOUNT-CHECK.md and results/mahatva/groq-account-console.json (15 Oct 2026). Demo-key association and project overrides were not independently established. Groq policy: https://console.groq.com/docs/your-data. Joint driver/narrator rehearsal remains pending. Do not show keys or raw logs.</a:t>
             </a:r>
           </a:p>
         </p:txBody>
@@ -4093,17 +4093,17 @@
   </p:cSld>
   <p:clrMap bg1="lt1" tx1="dk1" bg2="lt2" tx2="dk2" accent1="accent1" accent2="accent2" accent3="accent3" accent4="accent4" accent5="accent5" accent6="accent6" hlink="hlink" folHlink="folHlink"/>
   <p:sldLayoutIdLst>
-    <p:sldLayoutId xmlns:r="http://schemas.openxmlformats.org/officeDocument/2006/relationships" id="2147483649" r:id="R857a876c7ad94514"/>
-    <p:sldLayoutId xmlns:r="http://schemas.openxmlformats.org/officeDocument/2006/relationships" id="2147483650" r:id="Rbf7bf2fd2b284412"/>
-    <p:sldLayoutId xmlns:r="http://schemas.openxmlformats.org/officeDocument/2006/relationships" id="2147483651" r:id="R012de6335f2c4fc1"/>
-    <p:sldLayoutId xmlns:r="http://schemas.openxmlformats.org/officeDocument/2006/relationships" id="2147483652" r:id="R67bcd3aa6cfa452f"/>
-    <p:sldLayoutId xmlns:r="http://schemas.openxmlformats.org/officeDocument/2006/relationships" id="2147483653" r:id="R1bd7f98c8d744df3"/>
-    <p:sldLayoutId xmlns:r="http://schemas.openxmlformats.org/officeDocument/2006/relationships" id="2147483654" r:id="Rf576f9473a654ddf"/>
-    <p:sldLayoutId xmlns:r="http://schemas.openxmlformats.org/officeDocument/2006/relationships" id="2147483655" r:id="Rbfe6a89518174665"/>
-    <p:sldLayoutId xmlns:r="http://schemas.openxmlformats.org/officeDocument/2006/relationships" id="2147483656" r:id="R984f20f359704dad"/>
-    <p:sldLayoutId xmlns:r="http://schemas.openxmlformats.org/officeDocument/2006/relationships" id="2147483657" r:id="R0cc67aa71bd64b8a"/>
-    <p:sldLayoutId xmlns:r="http://schemas.openxmlformats.org/officeDocument/2006/relationships" id="2147483658" r:id="R89f4508bf4124f8a"/>
-    <p:sldLayoutId xmlns:r="http://schemas.openxmlformats.org/officeDocument/2006/relationships" id="2147483659" r:id="R20c970ea712846b8"/>
+    <p:sldLayoutId xmlns:r="http://schemas.openxmlformats.org/officeDocument/2006/relationships" id="2147483649" r:id="R58cd46c85e154132"/>
+    <p:sldLayoutId xmlns:r="http://schemas.openxmlformats.org/officeDocument/2006/relationships" id="2147483650" r:id="Rc2cbdffc88bd45b5"/>
+    <p:sldLayoutId xmlns:r="http://schemas.openxmlformats.org/officeDocument/2006/relationships" id="2147483651" r:id="R348a6ac3404d4ecf"/>
+    <p:sldLayoutId xmlns:r="http://schemas.openxmlformats.org/officeDocument/2006/relationships" id="2147483652" r:id="R169e0722cf9b435a"/>
+    <p:sldLayoutId xmlns:r="http://schemas.openxmlformats.org/officeDocument/2006/relationships" id="2147483653" r:id="R1904c0e6cdce44e4"/>
+    <p:sldLayoutId xmlns:r="http://schemas.openxmlformats.org/officeDocument/2006/relationships" id="2147483654" r:id="Rd59d6fe5744e47cb"/>
+    <p:sldLayoutId xmlns:r="http://schemas.openxmlformats.org/officeDocument/2006/relationships" id="2147483655" r:id="Re82e39e7ee3544c9"/>
+    <p:sldLayoutId xmlns:r="http://schemas.openxmlformats.org/officeDocument/2006/relationships" id="2147483656" r:id="Rb966e01873064f28"/>
+    <p:sldLayoutId xmlns:r="http://schemas.openxmlformats.org/officeDocument/2006/relationships" id="2147483657" r:id="R74cce8bde1ec4459"/>
+    <p:sldLayoutId xmlns:r="http://schemas.openxmlformats.org/officeDocument/2006/relationships" id="2147483658" r:id="Raa2dbdb1c0dc4cdc"/>
+    <p:sldLayoutId xmlns:r="http://schemas.openxmlformats.org/officeDocument/2006/relationships" id="2147483659" r:id="R717c8c949df34644"/>
   </p:sldLayoutIdLst>
   <p:txStyles>
     <p:titleStyle>
@@ -6164,7 +6164,7 @@
           <p:cNvPr id="5" name="Table 4">
             <a:extLst xmlns:a="http://schemas.openxmlformats.org/drawingml/2006/main">
               <a:ext uri="{FF2B5EF4-FFF2-40B4-BE49-F238E27FC236}">
-                <a16:creationId xmlns:a16="http://schemas.microsoft.com/office/drawing/2014/main" id="{18946758-3B63-4620-96AF-0E8B429F5536}"/>
+                <a16:creationId xmlns:a16="http://schemas.microsoft.com/office/drawing/2014/main" id="{00BB3EAB-23D4-4E20-A24C-E82AEF701991}"/>
               </a:ext>
             </a:extLst>
           </p:cNvPr>
@@ -6988,7 +6988,7 @@
           <p:cNvPr id="5" name="Table 4">
             <a:extLst xmlns:a="http://schemas.openxmlformats.org/drawingml/2006/main">
               <a:ext uri="{FF2B5EF4-FFF2-40B4-BE49-F238E27FC236}">
-                <a16:creationId xmlns:a16="http://schemas.microsoft.com/office/drawing/2014/main" id="{9D83D209-976F-4495-B6AD-075DE49CDB4F}"/>
+                <a16:creationId xmlns:a16="http://schemas.microsoft.com/office/drawing/2014/main" id="{32199BA7-3F6E-4945-8C40-8285B09B8201}"/>
               </a:ext>
             </a:extLst>
           </p:cNvPr>
@@ -7527,7 +7527,7 @@
           <p:cNvPr id="5" name="Table 4">
             <a:extLst xmlns:a="http://schemas.openxmlformats.org/drawingml/2006/main">
               <a:ext uri="{FF2B5EF4-FFF2-40B4-BE49-F238E27FC236}">
-                <a16:creationId xmlns:a16="http://schemas.microsoft.com/office/drawing/2014/main" id="{0A86DB9C-AA5C-41B6-86F3-99B8B961281D}"/>
+                <a16:creationId xmlns:a16="http://schemas.microsoft.com/office/drawing/2014/main" id="{808869C7-103F-480A-919D-781B8775D524}"/>
               </a:ext>
             </a:extLst>
           </p:cNvPr>
@@ -8086,7 +8086,7 @@
           <p:cNvPr id="5" name="Table 4">
             <a:extLst xmlns:a="http://schemas.openxmlformats.org/drawingml/2006/main">
               <a:ext uri="{FF2B5EF4-FFF2-40B4-BE49-F238E27FC236}">
-                <a16:creationId xmlns:a16="http://schemas.microsoft.com/office/drawing/2014/main" id="{52F1D6CF-FEA5-4099-ADA0-4D13B36D53E3}"/>
+                <a16:creationId xmlns:a16="http://schemas.microsoft.com/office/drawing/2014/main" id="{EE4C4F25-46DD-4498-A044-C637B26A7598}"/>
               </a:ext>
             </a:extLst>
           </p:cNvPr>
@@ -8665,7 +8665,7 @@
               </a:defRPr>
             </a:pPr>
             <a:r>
-              <a:t>Remaining: admin-confirmed ZDR and a joint Arihant/Ojaswi rehearsal. Proposed times are not booked.</a:t>
+              <a:t>Inference ZDR is disabled in the checked Personal organization; do not claim zero retention. Joint rehearsal remains pending.</a:t>
             </a:r>
           </a:p>
         </p:txBody>

</xml_diff>

<commit_message>
docs: finish Halo UI evidence and canonical demo deck
</commit_message>
<xml_diff>
--- a/docs/LeakShield-Freeze-v2.pptx
+++ b/docs/LeakShield-Freeze-v2.pptx
@@ -2,20 +2,20 @@
 <file path=ppt/presentation.xml><?xml version="1.0" encoding="utf-8"?>
 <p:presentation xmlns:p="http://schemas.openxmlformats.org/presentationml/2006/main">
   <p:sldMasterIdLst>
-    <p:sldMasterId xmlns:r="http://schemas.openxmlformats.org/officeDocument/2006/relationships" id="2147483648" r:id="R99bbdac70ce34035"/>
+    <p:sldMasterId xmlns:r="http://schemas.openxmlformats.org/officeDocument/2006/relationships" id="2147483648" r:id="R35b9f894be1f46af"/>
   </p:sldMasterIdLst>
   <p:notesMasterIdLst>
-    <p:notesMasterId xmlns:r="http://schemas.openxmlformats.org/officeDocument/2006/relationships" r:id="Rffde398143f34c5f"/>
+    <p:notesMasterId xmlns:r="http://schemas.openxmlformats.org/officeDocument/2006/relationships" r:id="R8e017d29b7d54651"/>
   </p:notesMasterIdLst>
   <p:sldIdLst>
-    <p:sldId xmlns:r="http://schemas.openxmlformats.org/officeDocument/2006/relationships" id="256" r:id="R153d5e68120847da"/>
-    <p:sldId xmlns:r="http://schemas.openxmlformats.org/officeDocument/2006/relationships" id="257" r:id="Rd15b523cbeda47b6"/>
-    <p:sldId xmlns:r="http://schemas.openxmlformats.org/officeDocument/2006/relationships" id="258" r:id="R5ca7ae5ac4b84021"/>
-    <p:sldId xmlns:r="http://schemas.openxmlformats.org/officeDocument/2006/relationships" id="259" r:id="R6477da31da7e4c55"/>
-    <p:sldId xmlns:r="http://schemas.openxmlformats.org/officeDocument/2006/relationships" id="260" r:id="R42a01bb9ee81450e"/>
-    <p:sldId xmlns:r="http://schemas.openxmlformats.org/officeDocument/2006/relationships" id="261" r:id="Ra6a7be1e98ac4b38"/>
-    <p:sldId xmlns:r="http://schemas.openxmlformats.org/officeDocument/2006/relationships" id="262" r:id="Rd3ef6489be724093"/>
-    <p:sldId xmlns:r="http://schemas.openxmlformats.org/officeDocument/2006/relationships" id="263" r:id="R64d29074f4134aba"/>
+    <p:sldId xmlns:r="http://schemas.openxmlformats.org/officeDocument/2006/relationships" id="256" r:id="Rc981d86ed3d94d9c"/>
+    <p:sldId xmlns:r="http://schemas.openxmlformats.org/officeDocument/2006/relationships" id="257" r:id="R5691b378fd174801"/>
+    <p:sldId xmlns:r="http://schemas.openxmlformats.org/officeDocument/2006/relationships" id="258" r:id="R7800762599d848d5"/>
+    <p:sldId xmlns:r="http://schemas.openxmlformats.org/officeDocument/2006/relationships" id="259" r:id="R61e6917a755a411a"/>
+    <p:sldId xmlns:r="http://schemas.openxmlformats.org/officeDocument/2006/relationships" id="260" r:id="R8daac5a191a742ef"/>
+    <p:sldId xmlns:r="http://schemas.openxmlformats.org/officeDocument/2006/relationships" id="261" r:id="Rc74de9b51ceb4df6"/>
+    <p:sldId xmlns:r="http://schemas.openxmlformats.org/officeDocument/2006/relationships" id="262" r:id="Rf1a7484a11d548a5"/>
+    <p:sldId xmlns:r="http://schemas.openxmlformats.org/officeDocument/2006/relationships" id="263" r:id="R7ce3290894384fe9"/>
   </p:sldIdLst>
   <p:sldSz cx="12191695" cy="6858000"/>
   <p:notesSz cx="6858000" cy="9144000"/>
@@ -786,7 +786,7 @@
           <a:lstStyle xmlns:a="http://schemas.openxmlformats.org/drawingml/2006/main"/>
           <a:p xmlns:a="http://schemas.openxmlformats.org/drawingml/2006/main">
             <a:r>
-              <a:t>Source: apps/gateway/src/approvals and approval-bridge.ts. Ten-minute encrypted memory queue, hash-bound single replay, metadata-only Mongo and fresh ACL/quarantine checks at completed-result polling. Restart discards ephemeral state.</a:t>
+              <a:t>Browser captures: docs/screenshots/garuda-pending.jpg, garuda-queue.jpg and garuda-approved.jpg. Source main 0c560db after UI PR #31 and ReDoS PR #25. Meera pending with zero calls, admin approval through Approvals, original conversation completed with one call. Real Groq openai/gpt-oss-120b, synthetic seed, 15 Oct 2026. This post-freeze smoke check is separate from the frozen 20b evaluation. Source: apps/gateway/src/approvals and approval-bridge.ts. Ten-minute encrypted memory queue, hash-bound single replay, metadata-only Mongo and fresh ACL/quarantine checks at completed-result polling. Restart discards ephemeral state.</a:t>
             </a:r>
           </a:p>
         </p:txBody>
@@ -4093,17 +4093,17 @@
   </p:cSld>
   <p:clrMap bg1="lt1" tx1="dk1" bg2="lt2" tx2="dk2" accent1="accent1" accent2="accent2" accent3="accent3" accent4="accent4" accent5="accent5" accent6="accent6" hlink="hlink" folHlink="folHlink"/>
   <p:sldLayoutIdLst>
-    <p:sldLayoutId xmlns:r="http://schemas.openxmlformats.org/officeDocument/2006/relationships" id="2147483649" r:id="R58cd46c85e154132"/>
-    <p:sldLayoutId xmlns:r="http://schemas.openxmlformats.org/officeDocument/2006/relationships" id="2147483650" r:id="Rc2cbdffc88bd45b5"/>
-    <p:sldLayoutId xmlns:r="http://schemas.openxmlformats.org/officeDocument/2006/relationships" id="2147483651" r:id="R348a6ac3404d4ecf"/>
-    <p:sldLayoutId xmlns:r="http://schemas.openxmlformats.org/officeDocument/2006/relationships" id="2147483652" r:id="R169e0722cf9b435a"/>
-    <p:sldLayoutId xmlns:r="http://schemas.openxmlformats.org/officeDocument/2006/relationships" id="2147483653" r:id="R1904c0e6cdce44e4"/>
-    <p:sldLayoutId xmlns:r="http://schemas.openxmlformats.org/officeDocument/2006/relationships" id="2147483654" r:id="Rd59d6fe5744e47cb"/>
-    <p:sldLayoutId xmlns:r="http://schemas.openxmlformats.org/officeDocument/2006/relationships" id="2147483655" r:id="Re82e39e7ee3544c9"/>
-    <p:sldLayoutId xmlns:r="http://schemas.openxmlformats.org/officeDocument/2006/relationships" id="2147483656" r:id="Rb966e01873064f28"/>
-    <p:sldLayoutId xmlns:r="http://schemas.openxmlformats.org/officeDocument/2006/relationships" id="2147483657" r:id="R74cce8bde1ec4459"/>
-    <p:sldLayoutId xmlns:r="http://schemas.openxmlformats.org/officeDocument/2006/relationships" id="2147483658" r:id="Raa2dbdb1c0dc4cdc"/>
-    <p:sldLayoutId xmlns:r="http://schemas.openxmlformats.org/officeDocument/2006/relationships" id="2147483659" r:id="R717c8c949df34644"/>
+    <p:sldLayoutId xmlns:r="http://schemas.openxmlformats.org/officeDocument/2006/relationships" id="2147483649" r:id="Rb4163260a48e4bb4"/>
+    <p:sldLayoutId xmlns:r="http://schemas.openxmlformats.org/officeDocument/2006/relationships" id="2147483650" r:id="R7c9779e2aee6469e"/>
+    <p:sldLayoutId xmlns:r="http://schemas.openxmlformats.org/officeDocument/2006/relationships" id="2147483651" r:id="R90c84c8676fb4d23"/>
+    <p:sldLayoutId xmlns:r="http://schemas.openxmlformats.org/officeDocument/2006/relationships" id="2147483652" r:id="R440392bd19dd40f3"/>
+    <p:sldLayoutId xmlns:r="http://schemas.openxmlformats.org/officeDocument/2006/relationships" id="2147483653" r:id="Ra77e3218347d4956"/>
+    <p:sldLayoutId xmlns:r="http://schemas.openxmlformats.org/officeDocument/2006/relationships" id="2147483654" r:id="R59e2e1ce79c44904"/>
+    <p:sldLayoutId xmlns:r="http://schemas.openxmlformats.org/officeDocument/2006/relationships" id="2147483655" r:id="R8378380f137242fa"/>
+    <p:sldLayoutId xmlns:r="http://schemas.openxmlformats.org/officeDocument/2006/relationships" id="2147483656" r:id="Rd5ff9ef3bf804d05"/>
+    <p:sldLayoutId xmlns:r="http://schemas.openxmlformats.org/officeDocument/2006/relationships" id="2147483657" r:id="Rf05d166dcebc461f"/>
+    <p:sldLayoutId xmlns:r="http://schemas.openxmlformats.org/officeDocument/2006/relationships" id="2147483658" r:id="R3cb66d9699f34cc3"/>
+    <p:sldLayoutId xmlns:r="http://schemas.openxmlformats.org/officeDocument/2006/relationships" id="2147483659" r:id="Rf02976a6d8ed45b5"/>
   </p:sldLayoutIdLst>
   <p:txStyles>
     <p:titleStyle>
@@ -6164,7 +6164,7 @@
           <p:cNvPr id="5" name="Table 4">
             <a:extLst xmlns:a="http://schemas.openxmlformats.org/drawingml/2006/main">
               <a:ext uri="{FF2B5EF4-FFF2-40B4-BE49-F238E27FC236}">
-                <a16:creationId xmlns:a16="http://schemas.microsoft.com/office/drawing/2014/main" id="{00BB3EAB-23D4-4E20-A24C-E82AEF701991}"/>
+                <a16:creationId xmlns:a16="http://schemas.microsoft.com/office/drawing/2014/main" id="{1C4F0A9F-A6F2-4DA1-A366-0AC44520891E}"/>
               </a:ext>
             </a:extLst>
           </p:cNvPr>
@@ -6670,8 +6670,8 @@
         </p:nvSpPr>
         <p:spPr>
           <a:xfrm xmlns:a="http://schemas.openxmlformats.org/drawingml/2006/main">
-            <a:off x="685800" y="1737360"/>
-            <a:ext cx="10789920" cy="1005840"/>
+            <a:off x="7086600" y="1638300"/>
+            <a:ext cx="4286250" cy="1085850"/>
           </a:xfrm>
           <a:prstGeom xmlns:a="http://schemas.openxmlformats.org/drawingml/2006/main" prst="rect">
             <a:avLst/>
@@ -6682,14 +6682,9 @@
           <a:bodyPr xmlns:a="http://schemas.openxmlformats.org/drawingml/2006/main" wrap="square">
             <a:spAutoFit/>
           </a:bodyPr>
-          <a:lstStyle xmlns:a="http://schemas.openxmlformats.org/drawingml/2006/main"/>
-          <a:p xmlns:a="http://schemas.openxmlformats.org/drawingml/2006/main">
-            <a:pPr>
-              <a:spcAft>
-                <a:spcPts val="1400"/>
-              </a:spcAft>
-              <a:buNone/>
-              <a:defRPr sz="2700" b="0">
+          <a:lstStyle xmlns:a="http://schemas.openxmlformats.org/drawingml/2006/main">
+            <a:defPPr>
+              <a:defRPr sz="2175">
                 <a:solidFill>
                   <a:srgbClr val="64DEB1"/>
                 </a:solidFill>
@@ -6697,9 +6692,33 @@
                 <a:ea typeface="Aptos"/>
                 <a:cs typeface="Aptos"/>
               </a:defRPr>
-            </a:pPr>
-            <a:r>
-              <a:t>Ingest source → scan hidden carriers → quarantine whole document</a:t>
+            </a:defPPr>
+          </a:lstStyle>
+          <a:p xmlns:a="http://schemas.openxmlformats.org/drawingml/2006/main">
+            <a:pPr>
+              <a:spcAft>
+                <a:spcPts val="1400"/>
+              </a:spcAft>
+              <a:buNone/>
+              <a:defRPr sz="2175" b="0">
+                <a:solidFill>
+                  <a:srgbClr val="64DEB1"/>
+                </a:solidFill>
+                <a:latin typeface="Aptos"/>
+                <a:ea typeface="Aptos"/>
+                <a:cs typeface="Aptos"/>
+              </a:defRPr>
+            </a:pPr>
+            <a:r>
+              <a:rPr sz="2175">
+                <a:solidFill>
+                  <a:srgbClr val="64DEB1"/>
+                </a:solidFill>
+                <a:latin typeface="Aptos"/>
+                <a:ea typeface="Aptos"/>
+                <a:cs typeface="Aptos"/>
+              </a:rPr>
+              <a:t>Hidden carriers trigger whole-document quarantine before rendering.</a:t>
             </a:r>
           </a:p>
         </p:txBody>
@@ -6720,8 +6739,8 @@
         </p:nvSpPr>
         <p:spPr>
           <a:xfrm xmlns:a="http://schemas.openxmlformats.org/drawingml/2006/main">
-            <a:off x="685800" y="2834640"/>
-            <a:ext cx="10607040" cy="1005840"/>
+            <a:off x="7086600" y="3390900"/>
+            <a:ext cx="4286250" cy="1634490"/>
           </a:xfrm>
           <a:prstGeom xmlns:a="http://schemas.openxmlformats.org/drawingml/2006/main" prst="rect">
             <a:avLst/>
@@ -6732,14 +6751,9 @@
           <a:bodyPr xmlns:a="http://schemas.openxmlformats.org/drawingml/2006/main" wrap="square">
             <a:spAutoFit/>
           </a:bodyPr>
-          <a:lstStyle xmlns:a="http://schemas.openxmlformats.org/drawingml/2006/main"/>
-          <a:p xmlns:a="http://schemas.openxmlformats.org/drawingml/2006/main">
-            <a:pPr>
-              <a:spcAft>
-                <a:spcPts val="1400"/>
-              </a:spcAft>
-              <a:buNone/>
-              <a:defRPr sz="2400" b="0">
+          <a:lstStyle xmlns:a="http://schemas.openxmlformats.org/drawingml/2006/main">
+            <a:defPPr>
+              <a:defRPr sz="2025">
                 <a:solidFill>
                   <a:srgbClr val="F1F5FA"/>
                 </a:solidFill>
@@ -6747,49 +6761,15 @@
                 <a:ea typeface="Aptos"/>
                 <a:cs typeface="Aptos"/>
               </a:defRPr>
-            </a:pPr>
-            <a:r>
-              <a:t>Comments, hidden CSS, white text, zero-width characters and alt/title attributes are checked before rendering.</a:t>
-            </a:r>
-          </a:p>
-        </p:txBody>
-      </p:sp>
-      <p:sp>
-        <p:nvSpPr>
-          <p:cNvPr id="6" name="TextBox 5">
-            <a:extLst xmlns:a="http://schemas.openxmlformats.org/drawingml/2006/main">
-              <a:ext uri="{FF2B5EF4-FFF2-40B4-BE49-F238E27FC236}">
-                <a16:creationId xmlns:a16="http://schemas.microsoft.com/office/drawing/2014/main" id="{AB5BFF6E-13D2-489A-A834-6CE7E0F7173A}"/>
-              </a:ext>
-            </a:extLst>
-          </p:cNvPr>
-          <p:cNvSpPr>
-            <a:spLocks xmlns:a="http://schemas.openxmlformats.org/drawingml/2006/main" noGrp="1"/>
-          </p:cNvSpPr>
-          <p:nvPr/>
-        </p:nvSpPr>
-        <p:spPr>
-          <a:xfrm xmlns:a="http://schemas.openxmlformats.org/drawingml/2006/main">
-            <a:off x="685800" y="4297680"/>
-            <a:ext cx="10607040" cy="1371600"/>
-          </a:xfrm>
-          <a:prstGeom xmlns:a="http://schemas.openxmlformats.org/drawingml/2006/main" prst="rect">
-            <a:avLst/>
-          </a:prstGeom>
-          <a:noFill xmlns:a="http://schemas.openxmlformats.org/drawingml/2006/main"/>
-        </p:spPr>
-        <p:txBody>
-          <a:bodyPr xmlns:a="http://schemas.openxmlformats.org/drawingml/2006/main" wrap="square">
-            <a:spAutoFit/>
-          </a:bodyPr>
-          <a:lstStyle xmlns:a="http://schemas.openxmlformats.org/drawingml/2006/main"/>
+            </a:defPPr>
+          </a:lstStyle>
           <a:p xmlns:a="http://schemas.openxmlformats.org/drawingml/2006/main">
             <a:pPr>
               <a:spcAft>
                 <a:spcPts val="1400"/>
               </a:spcAft>
               <a:buNone/>
-              <a:defRPr sz="2400" b="0">
+              <a:defRPr sz="2025" b="0">
                 <a:solidFill>
                   <a:srgbClr val="F1F5FA"/>
                 </a:solidFill>
@@ -6799,7 +6779,272 @@
               </a:defRPr>
             </a:pPr>
             <a:r>
-              <a:t>Pending requests use AES-GCM in memory for ten minutes. Mongo stores metadata and request hash. Approval is single use and rechecks current permissions.</a:t>
+              <a:rPr sz="2025">
+                <a:solidFill>
+                  <a:srgbClr val="F1F5FA"/>
+                </a:solidFill>
+                <a:latin typeface="Aptos"/>
+                <a:ea typeface="Aptos"/>
+                <a:cs typeface="Aptos"/>
+              </a:rPr>
+              <a:t>Approval holds the request in encrypted memory for ten minutes. Replay rechecks current access. Mongo stores metadata and the request hash.</a:t>
+            </a:r>
+          </a:p>
+        </p:txBody>
+      </p:sp>
+      <p:sp>
+        <p:nvSpPr>
+          <p:cNvPr id="6" name="TextBox 5">
+            <a:extLst xmlns:a="http://schemas.openxmlformats.org/drawingml/2006/main">
+              <a:ext uri="{FF2B5EF4-FFF2-40B4-BE49-F238E27FC236}">
+                <a16:creationId xmlns:a16="http://schemas.microsoft.com/office/drawing/2014/main" id="{AB5BFF6E-13D2-489A-A834-6CE7E0F7173A}"/>
+              </a:ext>
+            </a:extLst>
+          </p:cNvPr>
+          <p:cNvSpPr>
+            <a:spLocks xmlns:a="http://schemas.openxmlformats.org/drawingml/2006/main" noGrp="1"/>
+          </p:cNvSpPr>
+          <p:nvPr/>
+        </p:nvSpPr>
+        <p:spPr>
+          <a:xfrm xmlns:a="http://schemas.openxmlformats.org/drawingml/2006/main">
+            <a:off x="685800" y="6200775"/>
+            <a:ext cx="10058400" cy="274320"/>
+          </a:xfrm>
+          <a:prstGeom xmlns:a="http://schemas.openxmlformats.org/drawingml/2006/main" prst="rect">
+            <a:avLst/>
+          </a:prstGeom>
+          <a:noFill xmlns:a="http://schemas.openxmlformats.org/drawingml/2006/main"/>
+        </p:spPr>
+        <p:txBody>
+          <a:bodyPr xmlns:a="http://schemas.openxmlformats.org/drawingml/2006/main" wrap="square">
+            <a:spAutoFit/>
+          </a:bodyPr>
+          <a:lstStyle xmlns:a="http://schemas.openxmlformats.org/drawingml/2006/main">
+            <a:defPPr>
+              <a:defRPr sz="1200">
+                <a:solidFill>
+                  <a:srgbClr val="B6C3D7"/>
+                </a:solidFill>
+                <a:latin typeface="Aptos"/>
+                <a:ea typeface="Aptos"/>
+                <a:cs typeface="Aptos"/>
+              </a:defRPr>
+            </a:defPPr>
+          </a:lstStyle>
+          <a:p xmlns:a="http://schemas.openxmlformats.org/drawingml/2006/main">
+            <a:pPr>
+              <a:spcAft>
+                <a:spcPts val="1400"/>
+              </a:spcAft>
+              <a:buNone/>
+              <a:defRPr sz="1200" b="0">
+                <a:solidFill>
+                  <a:srgbClr val="B6C3D7"/>
+                </a:solidFill>
+                <a:latin typeface="Aptos"/>
+                <a:ea typeface="Aptos"/>
+                <a:cs typeface="Aptos"/>
+              </a:defRPr>
+            </a:pPr>
+            <a:r>
+              <a:rPr sz="1200">
+                <a:solidFill>
+                  <a:srgbClr val="B6C3D7"/>
+                </a:solidFill>
+                <a:latin typeface="Aptos"/>
+                <a:ea typeface="Aptos"/>
+                <a:cs typeface="Aptos"/>
+              </a:rPr>
+              <a:t>Actual UI check: main 0c560db, 15 Oct 2026. Synthetic data, real Groq gpt-oss-120b. Frozen slide 5 uses 20b.</a:t>
+            </a:r>
+          </a:p>
+        </p:txBody>
+      </p:sp>
+      <p:pic>
+        <p:nvPicPr>
+          <p:cNvPr id="7" name="">
+            <a:extLst xmlns:a="http://schemas.openxmlformats.org/drawingml/2006/main">
+              <a:ext uri="{FF2B5EF4-FFF2-40B4-BE49-F238E27FC236}">
+                <a16:creationId xmlns:a16="http://schemas.microsoft.com/office/drawing/2014/main" id="{10BA3ED1-5E1E-484A-B2B4-ADB7EF3E6FB8}"/>
+              </a:ext>
+            </a:extLst>
+          </p:cNvPr>
+          <p:cNvPicPr>
+            <a:picLocks xmlns:a="http://schemas.openxmlformats.org/drawingml/2006/main" noChangeAspect="1"/>
+          </p:cNvPicPr>
+          <p:nvPr/>
+        </p:nvPicPr>
+        <p:blipFill>
+          <a:blip xmlns:r="http://schemas.openxmlformats.org/officeDocument/2006/relationships" xmlns:a="http://schemas.openxmlformats.org/drawingml/2006/main" r:embed="R2ca26fe841014355"/>
+          <a:stretch xmlns:a="http://schemas.openxmlformats.org/drawingml/2006/main"/>
+        </p:blipFill>
+        <p:spPr>
+          <a:xfrm xmlns:a="http://schemas.openxmlformats.org/drawingml/2006/main">
+            <a:off x="685800" y="1600318"/>
+            <a:ext cx="2857500" cy="4028839"/>
+          </a:xfrm>
+          <a:prstGeom xmlns:a="http://schemas.openxmlformats.org/drawingml/2006/main" prst="rect">
+            <a:avLst/>
+          </a:prstGeom>
+        </p:spPr>
+      </p:pic>
+      <p:sp>
+        <p:nvSpPr>
+          <p:cNvPr id="8" name="garuda-pending-caption">
+            <a:extLst xmlns:a="http://schemas.openxmlformats.org/drawingml/2006/main">
+              <a:ext uri="{FF2B5EF4-FFF2-40B4-BE49-F238E27FC236}">
+                <a16:creationId xmlns:a16="http://schemas.microsoft.com/office/drawing/2014/main" id="{4125D37D-DD45-4EDE-9DB3-4572F87F5DCF}"/>
+              </a:ext>
+            </a:extLst>
+          </p:cNvPr>
+          <p:cNvSpPr>
+            <a:spLocks xmlns:a="http://schemas.openxmlformats.org/drawingml/2006/main" noGrp="1"/>
+          </p:cNvSpPr>
+          <p:nvPr/>
+        </p:nvSpPr>
+        <p:spPr>
+          <a:xfrm xmlns:a="http://schemas.openxmlformats.org/drawingml/2006/main">
+            <a:off x="685800" y="5753100"/>
+            <a:ext cx="2952750" cy="342900"/>
+          </a:xfrm>
+          <a:prstGeom xmlns:a="http://schemas.openxmlformats.org/drawingml/2006/main" prst="rect">
+            <a:avLst/>
+          </a:prstGeom>
+          <a:noFill xmlns:a="http://schemas.openxmlformats.org/drawingml/2006/main"/>
+          <a:ln xmlns:a="http://schemas.openxmlformats.org/drawingml/2006/main" w="0">
+            <a:noFill/>
+          </a:ln>
+        </p:spPr>
+        <p:txBody>
+          <a:bodyPr xmlns:a="http://schemas.openxmlformats.org/drawingml/2006/main"/>
+          <a:lstStyle xmlns:a="http://schemas.openxmlformats.org/drawingml/2006/main">
+            <a:defPPr>
+              <a:defRPr sz="1650">
+                <a:solidFill>
+                  <a:srgbClr val="64DEB1"/>
+                </a:solidFill>
+                <a:latin typeface="Aptos"/>
+                <a:ea typeface="Aptos"/>
+                <a:cs typeface="Aptos"/>
+              </a:defRPr>
+            </a:defPPr>
+          </a:lstStyle>
+          <a:p xmlns:a="http://schemas.openxmlformats.org/drawingml/2006/main">
+            <a:pPr>
+              <a:defRPr sz="1650">
+                <a:solidFill>
+                  <a:srgbClr val="64DEB1"/>
+                </a:solidFill>
+                <a:latin typeface="Aptos"/>
+                <a:ea typeface="Aptos"/>
+                <a:cs typeface="Aptos"/>
+              </a:defRPr>
+            </a:pPr>
+            <a:r>
+              <a:rPr sz="1650">
+                <a:solidFill>
+                  <a:srgbClr val="64DEB1"/>
+                </a:solidFill>
+                <a:latin typeface="Aptos"/>
+                <a:ea typeface="Aptos"/>
+                <a:cs typeface="Aptos"/>
+              </a:rPr>
+              <a:t>Pending: 0 model calls</a:t>
+            </a:r>
+          </a:p>
+        </p:txBody>
+      </p:sp>
+      <p:pic>
+        <p:nvPicPr>
+          <p:cNvPr id="9" name="">
+            <a:extLst xmlns:a="http://schemas.openxmlformats.org/drawingml/2006/main">
+              <a:ext uri="{FF2B5EF4-FFF2-40B4-BE49-F238E27FC236}">
+                <a16:creationId xmlns:a16="http://schemas.microsoft.com/office/drawing/2014/main" id="{7A7473EF-FD05-4C0B-8585-01FDFE12E44A}"/>
+              </a:ext>
+            </a:extLst>
+          </p:cNvPr>
+          <p:cNvPicPr>
+            <a:picLocks xmlns:a="http://schemas.openxmlformats.org/drawingml/2006/main" noChangeAspect="1"/>
+          </p:cNvPicPr>
+          <p:nvPr/>
+        </p:nvPicPr>
+        <p:blipFill>
+          <a:blip xmlns:r="http://schemas.openxmlformats.org/officeDocument/2006/relationships" xmlns:a="http://schemas.openxmlformats.org/drawingml/2006/main" r:embed="R733c1293a7694b35"/>
+          <a:stretch xmlns:a="http://schemas.openxmlformats.org/drawingml/2006/main"/>
+        </p:blipFill>
+        <p:spPr>
+          <a:xfrm xmlns:a="http://schemas.openxmlformats.org/drawingml/2006/main">
+            <a:off x="3790950" y="1600318"/>
+            <a:ext cx="2857500" cy="4028839"/>
+          </a:xfrm>
+          <a:prstGeom xmlns:a="http://schemas.openxmlformats.org/drawingml/2006/main" prst="rect">
+            <a:avLst/>
+          </a:prstGeom>
+        </p:spPr>
+      </p:pic>
+      <p:sp>
+        <p:nvSpPr>
+          <p:cNvPr id="10" name="garuda-approved-caption">
+            <a:extLst xmlns:a="http://schemas.openxmlformats.org/drawingml/2006/main">
+              <a:ext uri="{FF2B5EF4-FFF2-40B4-BE49-F238E27FC236}">
+                <a16:creationId xmlns:a16="http://schemas.microsoft.com/office/drawing/2014/main" id="{4B4AF96B-44B2-4722-B656-3A67A2F90DB9}"/>
+              </a:ext>
+            </a:extLst>
+          </p:cNvPr>
+          <p:cNvSpPr>
+            <a:spLocks xmlns:a="http://schemas.openxmlformats.org/drawingml/2006/main" noGrp="1"/>
+          </p:cNvSpPr>
+          <p:nvPr/>
+        </p:nvSpPr>
+        <p:spPr>
+          <a:xfrm xmlns:a="http://schemas.openxmlformats.org/drawingml/2006/main">
+            <a:off x="3790950" y="5753100"/>
+            <a:ext cx="2952750" cy="342900"/>
+          </a:xfrm>
+          <a:prstGeom xmlns:a="http://schemas.openxmlformats.org/drawingml/2006/main" prst="rect">
+            <a:avLst/>
+          </a:prstGeom>
+          <a:noFill xmlns:a="http://schemas.openxmlformats.org/drawingml/2006/main"/>
+          <a:ln xmlns:a="http://schemas.openxmlformats.org/drawingml/2006/main" w="0">
+            <a:noFill/>
+          </a:ln>
+        </p:spPr>
+        <p:txBody>
+          <a:bodyPr xmlns:a="http://schemas.openxmlformats.org/drawingml/2006/main"/>
+          <a:lstStyle xmlns:a="http://schemas.openxmlformats.org/drawingml/2006/main">
+            <a:defPPr>
+              <a:defRPr sz="1650">
+                <a:solidFill>
+                  <a:srgbClr val="64DEB1"/>
+                </a:solidFill>
+                <a:latin typeface="Aptos"/>
+                <a:ea typeface="Aptos"/>
+                <a:cs typeface="Aptos"/>
+              </a:defRPr>
+            </a:defPPr>
+          </a:lstStyle>
+          <a:p xmlns:a="http://schemas.openxmlformats.org/drawingml/2006/main">
+            <a:pPr>
+              <a:defRPr sz="1650">
+                <a:solidFill>
+                  <a:srgbClr val="64DEB1"/>
+                </a:solidFill>
+                <a:latin typeface="Aptos"/>
+                <a:ea typeface="Aptos"/>
+                <a:cs typeface="Aptos"/>
+              </a:defRPr>
+            </a:pPr>
+            <a:r>
+              <a:rPr sz="1650">
+                <a:solidFill>
+                  <a:srgbClr val="64DEB1"/>
+                </a:solidFill>
+                <a:latin typeface="Aptos"/>
+                <a:ea typeface="Aptos"/>
+                <a:cs typeface="Aptos"/>
+              </a:rPr>
+              <a:t>Approved: 1 model call</a:t>
             </a:r>
           </a:p>
         </p:txBody>
@@ -6988,7 +7233,7 @@
           <p:cNvPr id="5" name="Table 4">
             <a:extLst xmlns:a="http://schemas.openxmlformats.org/drawingml/2006/main">
               <a:ext uri="{FF2B5EF4-FFF2-40B4-BE49-F238E27FC236}">
-                <a16:creationId xmlns:a16="http://schemas.microsoft.com/office/drawing/2014/main" id="{32199BA7-3F6E-4945-8C40-8285B09B8201}"/>
+                <a16:creationId xmlns:a16="http://schemas.microsoft.com/office/drawing/2014/main" id="{802BB717-AEFD-4AAA-B257-162E60CD4620}"/>
               </a:ext>
             </a:extLst>
           </p:cNvPr>
@@ -7527,7 +7772,7 @@
           <p:cNvPr id="5" name="Table 4">
             <a:extLst xmlns:a="http://schemas.openxmlformats.org/drawingml/2006/main">
               <a:ext uri="{FF2B5EF4-FFF2-40B4-BE49-F238E27FC236}">
-                <a16:creationId xmlns:a16="http://schemas.microsoft.com/office/drawing/2014/main" id="{808869C7-103F-480A-919D-781B8775D524}"/>
+                <a16:creationId xmlns:a16="http://schemas.microsoft.com/office/drawing/2014/main" id="{E70EA243-DAA8-4C03-9566-03EE8B48CC52}"/>
               </a:ext>
             </a:extLst>
           </p:cNvPr>
@@ -8086,7 +8331,7 @@
           <p:cNvPr id="5" name="Table 4">
             <a:extLst xmlns:a="http://schemas.openxmlformats.org/drawingml/2006/main">
               <a:ext uri="{FF2B5EF4-FFF2-40B4-BE49-F238E27FC236}">
-                <a16:creationId xmlns:a16="http://schemas.microsoft.com/office/drawing/2014/main" id="{EE4C4F25-46DD-4498-A044-C637B26A7598}"/>
+                <a16:creationId xmlns:a16="http://schemas.microsoft.com/office/drawing/2014/main" id="{4E699EDF-EDF9-406C-A494-8775EC0B8184}"/>
               </a:ext>
             </a:extLst>
           </p:cNvPr>

</xml_diff>